<commit_message>
Updated Module 2 Wireframe
Updated Module 2 Wireframe
</commit_message>
<xml_diff>
--- a/Module 2 Assigment Wireframe.pptx
+++ b/Module 2 Assigment Wireframe.pptx
@@ -5,7 +5,7 @@
     <p:sldMasterId id="2147483648" r:id="rId1"/>
   </p:sldMasterIdLst>
   <p:notesMasterIdLst>
-    <p:notesMasterId r:id="rId15"/>
+    <p:notesMasterId r:id="rId14"/>
   </p:notesMasterIdLst>
   <p:sldIdLst>
     <p:sldId id="256" r:id="rId2"/>
@@ -20,7 +20,6 @@
     <p:sldId id="265" r:id="rId11"/>
     <p:sldId id="266" r:id="rId12"/>
     <p:sldId id="267" r:id="rId13"/>
-    <p:sldId id="268" r:id="rId14"/>
   </p:sldIdLst>
   <p:sldSz cx="12192000" cy="6858000"/>
   <p:notesSz cx="6858000" cy="9144000"/>
@@ -794,90 +793,6 @@
             <a:fld id="{F7021451-1387-4CA6-816F-3879F97B5CBC}" type="slidenum">
               <a:rPr lang="en-US"/>
               <a:t>12</a:t>
-            </a:fld>
-            <a:endParaRPr lang="en-US"/>
-          </a:p>
-        </p:txBody>
-      </p:sp>
-    </p:spTree>
-    <p:extLst>
-      <p:ext uri="{BB962C8B-B14F-4D97-AF65-F5344CB8AC3E}">
-        <p14:creationId xmlns:p14="http://schemas.microsoft.com/office/powerpoint/2010/main" val="1024086991"/>
-      </p:ext>
-    </p:extLst>
-  </p:cSld>
-  <p:clrMapOvr>
-    <a:masterClrMapping/>
-  </p:clrMapOvr>
-</p:notes>
-</file>
-
-<file path=ppt/notesSlides/notesSlide13.xml><?xml version="1.0" encoding="utf-8"?>
-<p:notes xmlns:a="http://schemas.openxmlformats.org/drawingml/2006/main" xmlns:r="http://schemas.openxmlformats.org/officeDocument/2006/relationships" xmlns:p="http://schemas.openxmlformats.org/presentationml/2006/main">
-  <p:cSld>
-    <p:spTree>
-      <p:nvGrpSpPr>
-        <p:cNvPr id="1" name=""/>
-        <p:cNvGrpSpPr/>
-        <p:nvPr/>
-      </p:nvGrpSpPr>
-      <p:grpSpPr>
-        <a:xfrm>
-          <a:off x="0" y="0"/>
-          <a:ext cx="0" cy="0"/>
-          <a:chOff x="0" y="0"/>
-          <a:chExt cx="0" cy="0"/>
-        </a:xfrm>
-      </p:grpSpPr>
-      <p:sp>
-        <p:nvSpPr>
-          <p:cNvPr id="2" name="Slide Image Placeholder 1"/>
-          <p:cNvSpPr>
-            <a:spLocks noGrp="1" noRot="1" noChangeAspect="1"/>
-          </p:cNvSpPr>
-          <p:nvPr>
-            <p:ph type="sldImg"/>
-          </p:nvPr>
-        </p:nvSpPr>
-        <p:spPr/>
-      </p:sp>
-      <p:sp>
-        <p:nvSpPr>
-          <p:cNvPr id="3" name="Notes Placeholder 2"/>
-          <p:cNvSpPr>
-            <a:spLocks noGrp="1"/>
-          </p:cNvSpPr>
-          <p:nvPr>
-            <p:ph type="body" idx="1"/>
-          </p:nvPr>
-        </p:nvSpPr>
-        <p:spPr/>
-        <p:txBody>
-          <a:bodyPr/>
-          <a:lstStyle/>
-          <a:p>
-            <a:endParaRPr lang="en-US" dirty="0"/>
-          </a:p>
-        </p:txBody>
-      </p:sp>
-      <p:sp>
-        <p:nvSpPr>
-          <p:cNvPr id="4" name="Slide Number Placeholder 3"/>
-          <p:cNvSpPr>
-            <a:spLocks noGrp="1"/>
-          </p:cNvSpPr>
-          <p:nvPr>
-            <p:ph type="sldNum" sz="quarter" idx="10"/>
-          </p:nvPr>
-        </p:nvSpPr>
-        <p:spPr/>
-        <p:txBody>
-          <a:bodyPr/>
-          <a:lstStyle/>
-          <a:p>
-            <a:fld id="{F7021451-1387-4CA6-816F-3879F97B5CBC}" type="slidenum">
-              <a:rPr lang="en-US"/>
-              <a:t>13</a:t>
             </a:fld>
             <a:endParaRPr lang="en-US"/>
           </a:p>
@@ -13996,1292 +13911,6 @@
               <a:t>Success message appears after confirmation.</a:t>
             </a:r>
             <a:endParaRPr lang="en-US" sz="620" dirty="0"/>
-          </a:p>
-        </p:txBody>
-      </p:sp>
-    </p:spTree>
-  </p:cSld>
-  <p:clrMapOvr>
-    <a:masterClrMapping/>
-  </p:clrMapOvr>
-</p:sld>
-</file>
-
-<file path=ppt/slides/slide13.xml><?xml version="1.0" encoding="utf-8"?>
-<p:sld xmlns:a="http://schemas.openxmlformats.org/drawingml/2006/main" xmlns:r="http://schemas.openxmlformats.org/officeDocument/2006/relationships" xmlns:p="http://schemas.openxmlformats.org/presentationml/2006/main">
-  <p:cSld>
-    <p:spTree>
-      <p:nvGrpSpPr>
-        <p:cNvPr id="1" name=""/>
-        <p:cNvGrpSpPr/>
-        <p:nvPr/>
-      </p:nvGrpSpPr>
-      <p:grpSpPr>
-        <a:xfrm>
-          <a:off x="0" y="0"/>
-          <a:ext cx="0" cy="0"/>
-          <a:chOff x="0" y="0"/>
-          <a:chExt cx="0" cy="0"/>
-        </a:xfrm>
-      </p:grpSpPr>
-      <p:sp>
-        <p:nvSpPr>
-          <p:cNvPr id="2" name="Text 0"/>
-          <p:cNvSpPr/>
-          <p:nvPr/>
-        </p:nvSpPr>
-        <p:spPr>
-          <a:xfrm>
-            <a:off x="502920" y="228600"/>
-            <a:ext cx="5943600" cy="365760"/>
-          </a:xfrm>
-          <a:prstGeom prst="rect">
-            <a:avLst/>
-          </a:prstGeom>
-          <a:noFill/>
-          <a:ln/>
-        </p:spPr>
-        <p:txBody>
-          <a:bodyPr wrap="square" lIns="381" tIns="381" rIns="381" bIns="381" rtlCol="0" anchor="ctr">
-            <a:normAutofit/>
-          </a:bodyPr>
-          <a:lstStyle/>
-          <a:p>
-            <a:pPr marL="0" indent="0" algn="l">
-              <a:buNone/>
-            </a:pPr>
-            <a:r>
-              <a:rPr lang="en-US" sz="2000" b="1" dirty="0">
-                <a:solidFill>
-                  <a:srgbClr val="132133"/>
-                </a:solidFill>
-                <a:latin typeface="Georgia" pitchFamily="34" charset="0"/>
-                <a:ea typeface="Georgia" pitchFamily="34" charset="-122"/>
-                <a:cs typeface="Georgia" pitchFamily="34" charset="-120"/>
-              </a:rPr>
-              <a:t>Prototype Approval Checklist</a:t>
-            </a:r>
-            <a:endParaRPr lang="en-US" sz="2000" dirty="0"/>
-          </a:p>
-        </p:txBody>
-      </p:sp>
-      <p:sp>
-        <p:nvSpPr>
-          <p:cNvPr id="3" name="Text 1"/>
-          <p:cNvSpPr/>
-          <p:nvPr/>
-        </p:nvSpPr>
-        <p:spPr>
-          <a:xfrm>
-            <a:off x="512064" y="630936"/>
-            <a:ext cx="6492240" cy="228600"/>
-          </a:xfrm>
-          <a:prstGeom prst="rect">
-            <a:avLst/>
-          </a:prstGeom>
-          <a:noFill/>
-          <a:ln/>
-        </p:spPr>
-        <p:txBody>
-          <a:bodyPr wrap="square" lIns="381" tIns="381" rIns="381" bIns="381" rtlCol="0" anchor="ctr">
-            <a:normAutofit/>
-          </a:bodyPr>
-          <a:lstStyle/>
-          <a:p>
-            <a:pPr marL="0" indent="0" algn="l">
-              <a:buNone/>
-            </a:pPr>
-            <a:r>
-              <a:rPr lang="en-US" sz="850" dirty="0">
-                <a:solidFill>
-                  <a:srgbClr val="536273"/>
-                </a:solidFill>
-                <a:latin typeface="Arial" pitchFamily="34" charset="0"/>
-                <a:ea typeface="Arial" pitchFamily="34" charset="-122"/>
-                <a:cs typeface="Arial" pitchFamily="34" charset="-120"/>
-              </a:rPr>
-              <a:t>Use this final slide to confirm the deck meets the assignment requirements before submission.</a:t>
-            </a:r>
-            <a:endParaRPr lang="en-US" sz="850" dirty="0"/>
-          </a:p>
-        </p:txBody>
-      </p:sp>
-      <p:sp>
-        <p:nvSpPr>
-          <p:cNvPr id="4" name="Text 2"/>
-          <p:cNvSpPr/>
-          <p:nvPr/>
-        </p:nvSpPr>
-        <p:spPr>
-          <a:xfrm>
-            <a:off x="8823960" y="256032"/>
-            <a:ext cx="2743200" cy="228600"/>
-          </a:xfrm>
-          <a:prstGeom prst="rect">
-            <a:avLst/>
-          </a:prstGeom>
-          <a:noFill/>
-          <a:ln/>
-        </p:spPr>
-        <p:txBody>
-          <a:bodyPr wrap="square" lIns="381" tIns="381" rIns="381" bIns="381" rtlCol="0" anchor="ctr">
-            <a:normAutofit/>
-          </a:bodyPr>
-          <a:lstStyle/>
-          <a:p>
-            <a:pPr marL="0" indent="0" algn="r">
-              <a:buNone/>
-            </a:pPr>
-            <a:r>
-              <a:rPr lang="en-US" sz="800" b="1" dirty="0">
-                <a:solidFill>
-                  <a:srgbClr val="536273"/>
-                </a:solidFill>
-                <a:latin typeface="Arial" pitchFamily="34" charset="0"/>
-                <a:ea typeface="Arial" pitchFamily="34" charset="-122"/>
-                <a:cs typeface="Arial" pitchFamily="34" charset="-120"/>
-              </a:rPr>
-              <a:t>Moffat Bay Lodge Prototype</a:t>
-            </a:r>
-            <a:endParaRPr lang="en-US" sz="800" dirty="0"/>
-          </a:p>
-        </p:txBody>
-      </p:sp>
-      <p:sp>
-        <p:nvSpPr>
-          <p:cNvPr id="5" name="Shape 3"/>
-          <p:cNvSpPr/>
-          <p:nvPr/>
-        </p:nvSpPr>
-        <p:spPr>
-          <a:xfrm>
-            <a:off x="694944" y="1097280"/>
-            <a:ext cx="5212080" cy="4343400"/>
-          </a:xfrm>
-          <a:prstGeom prst="roundRect">
-            <a:avLst>
-              <a:gd name="adj" fmla="val 2947"/>
-            </a:avLst>
-          </a:prstGeom>
-          <a:solidFill>
-            <a:srgbClr val="FFFFFF">
-              <a:alpha val="92000"/>
-            </a:srgbClr>
-          </a:solidFill>
-          <a:ln w="12700">
-            <a:solidFill>
-              <a:srgbClr val="E9DFCF"/>
-            </a:solidFill>
-            <a:prstDash val="solid"/>
-          </a:ln>
-          <a:effectLst>
-            <a:outerShdw blurRad="12700" dist="7620" dir="2700000" algn="bl" rotWithShape="0">
-              <a:srgbClr val="132133">
-                <a:alpha val="7000"/>
-              </a:srgbClr>
-            </a:outerShdw>
-          </a:effectLst>
-        </p:spPr>
-        <p:txBody>
-          <a:bodyPr/>
-          <a:lstStyle/>
-          <a:p>
-            <a:endParaRPr lang="en-US"/>
-          </a:p>
-        </p:txBody>
-      </p:sp>
-      <p:sp>
-        <p:nvSpPr>
-          <p:cNvPr id="6" name="Text 4"/>
-          <p:cNvSpPr/>
-          <p:nvPr/>
-        </p:nvSpPr>
-        <p:spPr>
-          <a:xfrm>
-            <a:off x="960120" y="1371600"/>
-            <a:ext cx="3474720" cy="256032"/>
-          </a:xfrm>
-          <a:prstGeom prst="rect">
-            <a:avLst/>
-          </a:prstGeom>
-          <a:noFill/>
-          <a:ln/>
-        </p:spPr>
-        <p:txBody>
-          <a:bodyPr wrap="square" lIns="381" tIns="381" rIns="381" bIns="381" rtlCol="0" anchor="ctr">
-            <a:normAutofit lnSpcReduction="10000"/>
-          </a:bodyPr>
-          <a:lstStyle/>
-          <a:p>
-            <a:pPr marL="0" indent="0" algn="l">
-              <a:buNone/>
-            </a:pPr>
-            <a:r>
-              <a:rPr lang="en-US" sz="1800" dirty="0">
-                <a:solidFill>
-                  <a:srgbClr val="132133"/>
-                </a:solidFill>
-                <a:latin typeface="Georgia" pitchFamily="34" charset="0"/>
-                <a:ea typeface="Georgia" pitchFamily="34" charset="-122"/>
-                <a:cs typeface="Georgia" pitchFamily="34" charset="-120"/>
-              </a:rPr>
-              <a:t>Included Website Pages</a:t>
-            </a:r>
-            <a:endParaRPr lang="en-US" sz="1800" dirty="0"/>
-          </a:p>
-        </p:txBody>
-      </p:sp>
-      <p:sp>
-        <p:nvSpPr>
-          <p:cNvPr id="7" name="Text 5"/>
-          <p:cNvSpPr/>
-          <p:nvPr/>
-        </p:nvSpPr>
-        <p:spPr>
-          <a:xfrm>
-            <a:off x="1005840" y="1847088"/>
-            <a:ext cx="4343400" cy="2331720"/>
-          </a:xfrm>
-          <a:prstGeom prst="rect">
-            <a:avLst/>
-          </a:prstGeom>
-          <a:noFill/>
-          <a:ln/>
-        </p:spPr>
-        <p:txBody>
-          <a:bodyPr wrap="square" lIns="381" tIns="381" rIns="381" bIns="381" rtlCol="0" anchor="ctr">
-            <a:normAutofit/>
-          </a:bodyPr>
-          <a:lstStyle/>
-          <a:p>
-            <a:pPr marL="0" indent="0" algn="l">
-              <a:buNone/>
-            </a:pPr>
-            <a:r>
-              <a:rPr lang="en-US" sz="1200" dirty="0">
-                <a:solidFill>
-                  <a:srgbClr val="2A3B50"/>
-                </a:solidFill>
-                <a:latin typeface="Arial" pitchFamily="34" charset="0"/>
-                <a:ea typeface="Arial" pitchFamily="34" charset="-122"/>
-                <a:cs typeface="Arial" pitchFamily="34" charset="-120"/>
-              </a:rPr>
-              <a:t>Home / Landing Mockup</a:t>
-            </a:r>
-            <a:endParaRPr lang="en-US" sz="1200" dirty="0"/>
-          </a:p>
-          <a:p>
-            <a:pPr marL="0" indent="0" algn="l">
-              <a:buNone/>
-            </a:pPr>
-            <a:r>
-              <a:rPr lang="en-US" sz="1200" dirty="0">
-                <a:solidFill>
-                  <a:srgbClr val="2A3B50"/>
-                </a:solidFill>
-                <a:latin typeface="Arial" pitchFamily="34" charset="0"/>
-                <a:ea typeface="Arial" pitchFamily="34" charset="-122"/>
-                <a:cs typeface="Arial" pitchFamily="34" charset="-120"/>
-              </a:rPr>
-              <a:t>About</a:t>
-            </a:r>
-            <a:endParaRPr lang="en-US" sz="1200" dirty="0"/>
-          </a:p>
-          <a:p>
-            <a:pPr marL="0" indent="0" algn="l">
-              <a:buNone/>
-            </a:pPr>
-            <a:r>
-              <a:rPr lang="en-US" sz="1200" dirty="0">
-                <a:solidFill>
-                  <a:srgbClr val="2A3B50"/>
-                </a:solidFill>
-                <a:latin typeface="Arial" pitchFamily="34" charset="0"/>
-                <a:ea typeface="Arial" pitchFamily="34" charset="-122"/>
-                <a:cs typeface="Arial" pitchFamily="34" charset="-120"/>
-              </a:rPr>
-              <a:t>Rooms &amp; Pricing</a:t>
-            </a:r>
-            <a:endParaRPr lang="en-US" sz="1200" dirty="0"/>
-          </a:p>
-          <a:p>
-            <a:pPr marL="0" indent="0" algn="l">
-              <a:buNone/>
-            </a:pPr>
-            <a:r>
-              <a:rPr lang="en-US" sz="1200" dirty="0">
-                <a:solidFill>
-                  <a:srgbClr val="2A3B50"/>
-                </a:solidFill>
-                <a:latin typeface="Arial" pitchFamily="34" charset="0"/>
-                <a:ea typeface="Arial" pitchFamily="34" charset="-122"/>
-                <a:cs typeface="Arial" pitchFamily="34" charset="-120"/>
-              </a:rPr>
-              <a:t>Attractions</a:t>
-            </a:r>
-            <a:endParaRPr lang="en-US" sz="1200" dirty="0"/>
-          </a:p>
-          <a:p>
-            <a:pPr marL="0" indent="0" algn="l">
-              <a:buNone/>
-            </a:pPr>
-            <a:r>
-              <a:rPr lang="en-US" sz="1200" dirty="0">
-                <a:solidFill>
-                  <a:srgbClr val="2A3B50"/>
-                </a:solidFill>
-                <a:latin typeface="Arial" pitchFamily="34" charset="0"/>
-                <a:ea typeface="Arial" pitchFamily="34" charset="-122"/>
-                <a:cs typeface="Arial" pitchFamily="34" charset="-120"/>
-              </a:rPr>
-              <a:t>Contact</a:t>
-            </a:r>
-            <a:endParaRPr lang="en-US" sz="1200" dirty="0"/>
-          </a:p>
-          <a:p>
-            <a:pPr marL="0" indent="0" algn="l">
-              <a:buNone/>
-            </a:pPr>
-            <a:r>
-              <a:rPr lang="en-US" sz="1200" dirty="0">
-                <a:solidFill>
-                  <a:srgbClr val="2A3B50"/>
-                </a:solidFill>
-                <a:latin typeface="Arial" pitchFamily="34" charset="0"/>
-                <a:ea typeface="Arial" pitchFamily="34" charset="-122"/>
-                <a:cs typeface="Arial" pitchFamily="34" charset="-120"/>
-              </a:rPr>
-              <a:t>Login</a:t>
-            </a:r>
-            <a:endParaRPr lang="en-US" sz="1200" dirty="0"/>
-          </a:p>
-          <a:p>
-            <a:pPr marL="0" indent="0" algn="l">
-              <a:buNone/>
-            </a:pPr>
-            <a:r>
-              <a:rPr lang="en-US" sz="1200" dirty="0">
-                <a:solidFill>
-                  <a:srgbClr val="2A3B50"/>
-                </a:solidFill>
-                <a:latin typeface="Arial" pitchFamily="34" charset="0"/>
-                <a:ea typeface="Arial" pitchFamily="34" charset="-122"/>
-                <a:cs typeface="Arial" pitchFamily="34" charset="-120"/>
-              </a:rPr>
-              <a:t>Register</a:t>
-            </a:r>
-            <a:endParaRPr lang="en-US" sz="1200" dirty="0"/>
-          </a:p>
-          <a:p>
-            <a:pPr marL="0" indent="0" algn="l">
-              <a:buNone/>
-            </a:pPr>
-            <a:r>
-              <a:rPr lang="en-US" sz="1200" dirty="0">
-                <a:solidFill>
-                  <a:srgbClr val="2A3B50"/>
-                </a:solidFill>
-                <a:latin typeface="Arial" pitchFamily="34" charset="0"/>
-                <a:ea typeface="Arial" pitchFamily="34" charset="-122"/>
-                <a:cs typeface="Arial" pitchFamily="34" charset="-120"/>
-              </a:rPr>
-              <a:t>Book Your Stay</a:t>
-            </a:r>
-            <a:endParaRPr lang="en-US" sz="1200" dirty="0"/>
-          </a:p>
-          <a:p>
-            <a:pPr marL="0" indent="0" algn="l">
-              <a:buNone/>
-            </a:pPr>
-            <a:r>
-              <a:rPr lang="en-US" sz="1200" dirty="0">
-                <a:solidFill>
-                  <a:srgbClr val="2A3B50"/>
-                </a:solidFill>
-                <a:latin typeface="Arial" pitchFamily="34" charset="0"/>
-                <a:ea typeface="Arial" pitchFamily="34" charset="-122"/>
-                <a:cs typeface="Arial" pitchFamily="34" charset="-120"/>
-              </a:rPr>
-              <a:t>Reservation Lookup</a:t>
-            </a:r>
-            <a:endParaRPr lang="en-US" sz="1200" dirty="0"/>
-          </a:p>
-          <a:p>
-            <a:pPr marL="0" indent="0" algn="l">
-              <a:buNone/>
-            </a:pPr>
-            <a:r>
-              <a:rPr lang="en-US" sz="1200" dirty="0">
-                <a:solidFill>
-                  <a:srgbClr val="2A3B50"/>
-                </a:solidFill>
-                <a:latin typeface="Arial" pitchFamily="34" charset="0"/>
-                <a:ea typeface="Arial" pitchFamily="34" charset="-122"/>
-                <a:cs typeface="Arial" pitchFamily="34" charset="-120"/>
-              </a:rPr>
-              <a:t>Reservation Summary</a:t>
-            </a:r>
-            <a:endParaRPr lang="en-US" sz="1200" dirty="0"/>
-          </a:p>
-        </p:txBody>
-      </p:sp>
-      <p:sp>
-        <p:nvSpPr>
-          <p:cNvPr id="8" name="Shape 6"/>
-          <p:cNvSpPr/>
-          <p:nvPr/>
-        </p:nvSpPr>
-        <p:spPr>
-          <a:xfrm>
-            <a:off x="6263640" y="1097280"/>
-            <a:ext cx="5166360" cy="4343400"/>
-          </a:xfrm>
-          <a:prstGeom prst="roundRect">
-            <a:avLst>
-              <a:gd name="adj" fmla="val 2947"/>
-            </a:avLst>
-          </a:prstGeom>
-          <a:solidFill>
-            <a:srgbClr val="132133">
-              <a:alpha val="98000"/>
-            </a:srgbClr>
-          </a:solidFill>
-          <a:ln w="12700">
-            <a:solidFill>
-              <a:srgbClr val="132133"/>
-            </a:solidFill>
-            <a:prstDash val="solid"/>
-          </a:ln>
-          <a:effectLst>
-            <a:outerShdw blurRad="12700" dist="10160" dir="2700000" algn="bl" rotWithShape="0">
-              <a:srgbClr val="132133">
-                <a:alpha val="10000"/>
-              </a:srgbClr>
-            </a:outerShdw>
-          </a:effectLst>
-        </p:spPr>
-        <p:txBody>
-          <a:bodyPr/>
-          <a:lstStyle/>
-          <a:p>
-            <a:endParaRPr lang="en-US"/>
-          </a:p>
-        </p:txBody>
-      </p:sp>
-      <p:sp>
-        <p:nvSpPr>
-          <p:cNvPr id="9" name="Text 7"/>
-          <p:cNvSpPr/>
-          <p:nvPr/>
-        </p:nvSpPr>
-        <p:spPr>
-          <a:xfrm>
-            <a:off x="6556248" y="1371600"/>
-            <a:ext cx="4297680" cy="256032"/>
-          </a:xfrm>
-          <a:prstGeom prst="rect">
-            <a:avLst/>
-          </a:prstGeom>
-          <a:noFill/>
-          <a:ln/>
-        </p:spPr>
-        <p:txBody>
-          <a:bodyPr wrap="square" lIns="381" tIns="381" rIns="381" bIns="381" rtlCol="0" anchor="ctr">
-            <a:normAutofit lnSpcReduction="10000"/>
-          </a:bodyPr>
-          <a:lstStyle/>
-          <a:p>
-            <a:pPr marL="0" indent="0" algn="l">
-              <a:buNone/>
-            </a:pPr>
-            <a:r>
-              <a:rPr lang="en-US" sz="1800" dirty="0">
-                <a:solidFill>
-                  <a:srgbClr val="FFFFFF"/>
-                </a:solidFill>
-                <a:latin typeface="Georgia" pitchFamily="34" charset="0"/>
-                <a:ea typeface="Georgia" pitchFamily="34" charset="-122"/>
-                <a:cs typeface="Georgia" pitchFamily="34" charset="-120"/>
-              </a:rPr>
-              <a:t>What the Professor Can Review</a:t>
-            </a:r>
-            <a:endParaRPr lang="en-US" sz="1800" dirty="0"/>
-          </a:p>
-        </p:txBody>
-      </p:sp>
-      <p:sp>
-        <p:nvSpPr>
-          <p:cNvPr id="10" name="Text 8"/>
-          <p:cNvSpPr/>
-          <p:nvPr/>
-        </p:nvSpPr>
-        <p:spPr>
-          <a:xfrm>
-            <a:off x="6583680" y="1847088"/>
-            <a:ext cx="4434840" cy="2468880"/>
-          </a:xfrm>
-          <a:prstGeom prst="rect">
-            <a:avLst/>
-          </a:prstGeom>
-          <a:noFill/>
-          <a:ln/>
-        </p:spPr>
-        <p:txBody>
-          <a:bodyPr wrap="square" lIns="381" tIns="381" rIns="381" bIns="381" rtlCol="0" anchor="t">
-            <a:normAutofit/>
-          </a:bodyPr>
-          <a:lstStyle/>
-          <a:p>
-            <a:pPr marL="0" indent="0" algn="l">
-              <a:buNone/>
-            </a:pPr>
-            <a:r>
-              <a:rPr lang="en-US" sz="1100" dirty="0">
-                <a:solidFill>
-                  <a:srgbClr val="FFFFFF"/>
-                </a:solidFill>
-                <a:latin typeface="Arial" pitchFamily="34" charset="0"/>
-                <a:ea typeface="Arial" pitchFamily="34" charset="-122"/>
-                <a:cs typeface="Arial" pitchFamily="34" charset="-120"/>
-              </a:rPr>
-              <a:t>• Realistic landing page mockup with colors, layout, fonts, cards, and CTAs</a:t>
-            </a:r>
-            <a:endParaRPr lang="en-US" sz="1100" dirty="0"/>
-          </a:p>
-          <a:p>
-            <a:pPr marL="0" indent="0" algn="l">
-              <a:buNone/>
-            </a:pPr>
-            <a:r>
-              <a:rPr lang="en-US" sz="1100" dirty="0">
-                <a:solidFill>
-                  <a:srgbClr val="FFFFFF"/>
-                </a:solidFill>
-                <a:latin typeface="Arial" pitchFamily="34" charset="0"/>
-                <a:ea typeface="Arial" pitchFamily="34" charset="-122"/>
-                <a:cs typeface="Arial" pitchFamily="34" charset="-120"/>
-              </a:rPr>
-              <a:t>• Functional prototype pages for every website screen</a:t>
-            </a:r>
-            <a:endParaRPr lang="en-US" sz="1100" dirty="0"/>
-          </a:p>
-          <a:p>
-            <a:pPr marL="0" indent="0" algn="l">
-              <a:buNone/>
-            </a:pPr>
-            <a:r>
-              <a:rPr lang="en-US" sz="1100" dirty="0">
-                <a:solidFill>
-                  <a:srgbClr val="FFFFFF"/>
-                </a:solidFill>
-                <a:latin typeface="Arial" pitchFamily="34" charset="0"/>
-                <a:ea typeface="Arial" pitchFamily="34" charset="-122"/>
-                <a:cs typeface="Arial" pitchFamily="34" charset="-120"/>
-              </a:rPr>
-              <a:t>• Clickable navigation links in the header, buttons, and footer nav</a:t>
-            </a:r>
-            <a:endParaRPr lang="en-US" sz="1100" dirty="0"/>
-          </a:p>
-          <a:p>
-            <a:pPr marL="0" indent="0" algn="l">
-              <a:buNone/>
-            </a:pPr>
-            <a:r>
-              <a:rPr lang="en-US" sz="1100" dirty="0">
-                <a:solidFill>
-                  <a:srgbClr val="FFFFFF"/>
-                </a:solidFill>
-                <a:latin typeface="Arial" pitchFamily="34" charset="0"/>
-                <a:ea typeface="Arial" pitchFamily="34" charset="-122"/>
-                <a:cs typeface="Arial" pitchFamily="34" charset="-120"/>
-              </a:rPr>
-              <a:t>• Editable PowerPoint elements instead of flat page screenshots</a:t>
-            </a:r>
-            <a:endParaRPr lang="en-US" sz="1100" dirty="0"/>
-          </a:p>
-          <a:p>
-            <a:pPr marL="0" indent="0" algn="l">
-              <a:buNone/>
-            </a:pPr>
-            <a:r>
-              <a:rPr lang="en-US" sz="1100" dirty="0">
-                <a:solidFill>
-                  <a:srgbClr val="FFFFFF"/>
-                </a:solidFill>
-                <a:latin typeface="Arial" pitchFamily="34" charset="0"/>
-                <a:ea typeface="Arial" pitchFamily="34" charset="-122"/>
-                <a:cs typeface="Arial" pitchFamily="34" charset="-120"/>
-              </a:rPr>
-              <a:t>• Primary booking flow clearly shown from landing page to summary</a:t>
-            </a:r>
-            <a:endParaRPr lang="en-US" sz="1100" dirty="0"/>
-          </a:p>
-        </p:txBody>
-      </p:sp>
-      <p:sp>
-        <p:nvSpPr>
-          <p:cNvPr id="11" name="Shape 9">
-            <a:hlinkClick r:id="rId3" action="ppaction://hlinksldjump"/>
-          </p:cNvPr>
-          <p:cNvSpPr/>
-          <p:nvPr/>
-        </p:nvSpPr>
-        <p:spPr>
-          <a:xfrm>
-            <a:off x="6583680" y="4681728"/>
-            <a:ext cx="1325880" cy="310896"/>
-          </a:xfrm>
-          <a:prstGeom prst="roundRect">
-            <a:avLst>
-              <a:gd name="adj" fmla="val 35294"/>
-            </a:avLst>
-          </a:prstGeom>
-          <a:solidFill>
-            <a:srgbClr val="CDA059"/>
-          </a:solidFill>
-          <a:ln w="12700">
-            <a:solidFill>
-              <a:srgbClr val="CDA059">
-                <a:alpha val="0"/>
-              </a:srgbClr>
-            </a:solidFill>
-            <a:prstDash val="solid"/>
-          </a:ln>
-        </p:spPr>
-        <p:txBody>
-          <a:bodyPr/>
-          <a:lstStyle/>
-          <a:p>
-            <a:endParaRPr lang="en-US"/>
-          </a:p>
-        </p:txBody>
-      </p:sp>
-      <p:sp>
-        <p:nvSpPr>
-          <p:cNvPr id="12" name="Text 10">
-            <a:hlinkClick r:id="rId3" action="ppaction://hlinksldjump"/>
-          </p:cNvPr>
-          <p:cNvSpPr/>
-          <p:nvPr/>
-        </p:nvSpPr>
-        <p:spPr>
-          <a:xfrm>
-            <a:off x="6611112" y="4764024"/>
-            <a:ext cx="1271016" cy="109728"/>
-          </a:xfrm>
-          <a:prstGeom prst="rect">
-            <a:avLst/>
-          </a:prstGeom>
-          <a:noFill/>
-          <a:ln/>
-        </p:spPr>
-        <p:txBody>
-          <a:bodyPr wrap="square" lIns="381" tIns="381" rIns="381" bIns="381" rtlCol="0" anchor="ctr">
-            <a:normAutofit/>
-          </a:bodyPr>
-          <a:lstStyle/>
-          <a:p>
-            <a:pPr marL="0" indent="0" algn="ctr">
-              <a:buNone/>
-            </a:pPr>
-            <a:r>
-              <a:rPr lang="en-US" sz="640" b="1" u="sng" dirty="0">
-                <a:solidFill>
-                  <a:srgbClr val="132133"/>
-                </a:solidFill>
-                <a:latin typeface="Arial" pitchFamily="34" charset="0"/>
-                <a:ea typeface="Arial" pitchFamily="34" charset="-122"/>
-                <a:cs typeface="Arial" pitchFamily="34" charset="-120"/>
-                <a:hlinkClick r:id="rId3" action="ppaction://hlinksldjump">
-                  <a:extLst>
-                    <a:ext uri="{A12FA001-AC4F-418D-AE19-62706E023703}">
-                      <ahyp:hlinkClr xmlns:ahyp="http://schemas.microsoft.com/office/drawing/2018/hyperlinkcolor" val="tx"/>
-                    </a:ext>
-                  </a:extLst>
-                </a:hlinkClick>
-              </a:rPr>
-              <a:t>Back to Site Flow</a:t>
-            </a:r>
-            <a:endParaRPr lang="en-US" sz="640" dirty="0"/>
-          </a:p>
-        </p:txBody>
-      </p:sp>
-      <p:sp>
-        <p:nvSpPr>
-          <p:cNvPr id="13" name="Shape 11">
-            <a:hlinkClick r:id="rId4" action="ppaction://hlinksldjump"/>
-          </p:cNvPr>
-          <p:cNvSpPr/>
-          <p:nvPr/>
-        </p:nvSpPr>
-        <p:spPr>
-          <a:xfrm>
-            <a:off x="8092440" y="4681728"/>
-            <a:ext cx="1115568" cy="310896"/>
-          </a:xfrm>
-          <a:prstGeom prst="roundRect">
-            <a:avLst>
-              <a:gd name="adj" fmla="val 35294"/>
-            </a:avLst>
-          </a:prstGeom>
-          <a:solidFill>
-            <a:srgbClr val="FFFFFF">
-              <a:alpha val="30000"/>
-            </a:srgbClr>
-          </a:solidFill>
-          <a:ln w="12700">
-            <a:solidFill>
-              <a:srgbClr val="536273">
-                <a:alpha val="70000"/>
-              </a:srgbClr>
-            </a:solidFill>
-            <a:prstDash val="solid"/>
-          </a:ln>
-        </p:spPr>
-        <p:txBody>
-          <a:bodyPr/>
-          <a:lstStyle/>
-          <a:p>
-            <a:endParaRPr lang="en-US"/>
-          </a:p>
-        </p:txBody>
-      </p:sp>
-      <p:sp>
-        <p:nvSpPr>
-          <p:cNvPr id="14" name="Text 12">
-            <a:hlinkClick r:id="rId4" action="ppaction://hlinksldjump"/>
-          </p:cNvPr>
-          <p:cNvSpPr/>
-          <p:nvPr/>
-        </p:nvSpPr>
-        <p:spPr>
-          <a:xfrm>
-            <a:off x="8119872" y="4764024"/>
-            <a:ext cx="1060704" cy="109728"/>
-          </a:xfrm>
-          <a:prstGeom prst="rect">
-            <a:avLst/>
-          </a:prstGeom>
-          <a:noFill/>
-          <a:ln/>
-        </p:spPr>
-        <p:txBody>
-          <a:bodyPr wrap="square" lIns="381" tIns="381" rIns="381" bIns="381" rtlCol="0" anchor="ctr">
-            <a:normAutofit/>
-          </a:bodyPr>
-          <a:lstStyle/>
-          <a:p>
-            <a:pPr marL="0" indent="0" algn="ctr">
-              <a:buNone/>
-            </a:pPr>
-            <a:r>
-              <a:rPr lang="en-US" sz="640" b="1" u="sng" dirty="0">
-                <a:solidFill>
-                  <a:srgbClr val="132133"/>
-                </a:solidFill>
-                <a:latin typeface="Arial" pitchFamily="34" charset="0"/>
-                <a:ea typeface="Arial" pitchFamily="34" charset="-122"/>
-                <a:cs typeface="Arial" pitchFamily="34" charset="-120"/>
-                <a:hlinkClick r:id="rId4" action="ppaction://hlinksldjump">
-                  <a:extLst>
-                    <a:ext uri="{A12FA001-AC4F-418D-AE19-62706E023703}">
-                      <ahyp:hlinkClr xmlns:ahyp="http://schemas.microsoft.com/office/drawing/2018/hyperlinkcolor" val="tx"/>
-                    </a:ext>
-                  </a:extLst>
-                </a:hlinkClick>
-              </a:rPr>
-              <a:t>Start at Home</a:t>
-            </a:r>
-            <a:endParaRPr lang="en-US" sz="640" dirty="0"/>
-          </a:p>
-        </p:txBody>
-      </p:sp>
-      <p:sp>
-        <p:nvSpPr>
-          <p:cNvPr id="15" name="Text 13"/>
-          <p:cNvSpPr/>
-          <p:nvPr/>
-        </p:nvSpPr>
-        <p:spPr>
-          <a:xfrm>
-            <a:off x="502920" y="6510528"/>
-            <a:ext cx="6400800" cy="201168"/>
-          </a:xfrm>
-          <a:prstGeom prst="rect">
-            <a:avLst/>
-          </a:prstGeom>
-          <a:noFill/>
-          <a:ln/>
-        </p:spPr>
-        <p:txBody>
-          <a:bodyPr wrap="square" lIns="381" tIns="381" rIns="381" bIns="381" rtlCol="0" anchor="ctr">
-            <a:normAutofit/>
-          </a:bodyPr>
-          <a:lstStyle/>
-          <a:p>
-            <a:pPr marL="0" indent="0" algn="l">
-              <a:buNone/>
-            </a:pPr>
-            <a:r>
-              <a:rPr lang="en-US" sz="710" dirty="0">
-                <a:solidFill>
-                  <a:srgbClr val="536273"/>
-                </a:solidFill>
-                <a:latin typeface="Arial" pitchFamily="34" charset="0"/>
-                <a:ea typeface="Arial" pitchFamily="34" charset="-122"/>
-                <a:cs typeface="Arial" pitchFamily="34" charset="-120"/>
-              </a:rPr>
-              <a:t>Slide 13 | Editable components | Use Slide Show mode to click through the prototype</a:t>
-            </a:r>
-            <a:endParaRPr lang="en-US" sz="710" dirty="0"/>
-          </a:p>
-        </p:txBody>
-      </p:sp>
-      <p:sp>
-        <p:nvSpPr>
-          <p:cNvPr id="16" name="Shape 14">
-            <a:hlinkClick r:id="rId4" action="ppaction://hlinksldjump"/>
-          </p:cNvPr>
-          <p:cNvSpPr/>
-          <p:nvPr/>
-        </p:nvSpPr>
-        <p:spPr>
-          <a:xfrm>
-            <a:off x="7635240" y="6455664"/>
-            <a:ext cx="749808" cy="283464"/>
-          </a:xfrm>
-          <a:prstGeom prst="roundRect">
-            <a:avLst>
-              <a:gd name="adj" fmla="val 25806"/>
-            </a:avLst>
-          </a:prstGeom>
-          <a:solidFill>
-            <a:srgbClr val="FFFFFF">
-              <a:alpha val="30000"/>
-            </a:srgbClr>
-          </a:solidFill>
-          <a:ln w="12700">
-            <a:solidFill>
-              <a:srgbClr val="536273">
-                <a:alpha val="50000"/>
-              </a:srgbClr>
-            </a:solidFill>
-            <a:prstDash val="solid"/>
-          </a:ln>
-        </p:spPr>
-        <p:txBody>
-          <a:bodyPr/>
-          <a:lstStyle/>
-          <a:p>
-            <a:endParaRPr lang="en-US"/>
-          </a:p>
-        </p:txBody>
-      </p:sp>
-      <p:sp>
-        <p:nvSpPr>
-          <p:cNvPr id="17" name="Text 15">
-            <a:hlinkClick r:id="rId4" action="ppaction://hlinksldjump"/>
-          </p:cNvPr>
-          <p:cNvSpPr/>
-          <p:nvPr/>
-        </p:nvSpPr>
-        <p:spPr>
-          <a:xfrm>
-            <a:off x="7653528" y="6483096"/>
-            <a:ext cx="713232" cy="182880"/>
-          </a:xfrm>
-          <a:prstGeom prst="rect">
-            <a:avLst/>
-          </a:prstGeom>
-          <a:noFill/>
-          <a:ln/>
-        </p:spPr>
-        <p:txBody>
-          <a:bodyPr wrap="square" lIns="381" tIns="381" rIns="381" bIns="381" rtlCol="0" anchor="ctr">
-            <a:normAutofit/>
-          </a:bodyPr>
-          <a:lstStyle/>
-          <a:p>
-            <a:pPr marL="0" indent="0" algn="ctr">
-              <a:buNone/>
-            </a:pPr>
-            <a:r>
-              <a:rPr lang="en-US" sz="800" b="1" u="sng" dirty="0">
-                <a:solidFill>
-                  <a:srgbClr val="2A3B50"/>
-                </a:solidFill>
-                <a:latin typeface="Arial" pitchFamily="34" charset="0"/>
-                <a:ea typeface="Arial" pitchFamily="34" charset="-122"/>
-                <a:cs typeface="Arial" pitchFamily="34" charset="-120"/>
-                <a:hlinkClick r:id="rId4" action="ppaction://hlinksldjump">
-                  <a:extLst>
-                    <a:ext uri="{A12FA001-AC4F-418D-AE19-62706E023703}">
-                      <ahyp:hlinkClr xmlns:ahyp="http://schemas.microsoft.com/office/drawing/2018/hyperlinkcolor" val="tx"/>
-                    </a:ext>
-                  </a:extLst>
-                </a:hlinkClick>
-              </a:rPr>
-              <a:t>Home</a:t>
-            </a:r>
-            <a:endParaRPr lang="en-US" sz="800" dirty="0"/>
-          </a:p>
-        </p:txBody>
-      </p:sp>
-      <p:sp>
-        <p:nvSpPr>
-          <p:cNvPr id="18" name="Shape 16">
-            <a:hlinkClick r:id="rId5" action="ppaction://hlinksldjump"/>
-          </p:cNvPr>
-          <p:cNvSpPr/>
-          <p:nvPr/>
-        </p:nvSpPr>
-        <p:spPr>
-          <a:xfrm>
-            <a:off x="8476488" y="6455664"/>
-            <a:ext cx="749808" cy="283464"/>
-          </a:xfrm>
-          <a:prstGeom prst="roundRect">
-            <a:avLst>
-              <a:gd name="adj" fmla="val 25806"/>
-            </a:avLst>
-          </a:prstGeom>
-          <a:solidFill>
-            <a:srgbClr val="FFFFFF">
-              <a:alpha val="30000"/>
-            </a:srgbClr>
-          </a:solidFill>
-          <a:ln w="12700">
-            <a:solidFill>
-              <a:srgbClr val="536273">
-                <a:alpha val="50000"/>
-              </a:srgbClr>
-            </a:solidFill>
-            <a:prstDash val="solid"/>
-          </a:ln>
-        </p:spPr>
-        <p:txBody>
-          <a:bodyPr/>
-          <a:lstStyle/>
-          <a:p>
-            <a:endParaRPr lang="en-US"/>
-          </a:p>
-        </p:txBody>
-      </p:sp>
-      <p:sp>
-        <p:nvSpPr>
-          <p:cNvPr id="19" name="Text 17">
-            <a:hlinkClick r:id="rId5" action="ppaction://hlinksldjump"/>
-          </p:cNvPr>
-          <p:cNvSpPr/>
-          <p:nvPr/>
-        </p:nvSpPr>
-        <p:spPr>
-          <a:xfrm>
-            <a:off x="8494776" y="6483096"/>
-            <a:ext cx="713232" cy="182880"/>
-          </a:xfrm>
-          <a:prstGeom prst="rect">
-            <a:avLst/>
-          </a:prstGeom>
-          <a:noFill/>
-          <a:ln/>
-        </p:spPr>
-        <p:txBody>
-          <a:bodyPr wrap="square" lIns="381" tIns="381" rIns="381" bIns="381" rtlCol="0" anchor="ctr">
-            <a:normAutofit/>
-          </a:bodyPr>
-          <a:lstStyle/>
-          <a:p>
-            <a:pPr marL="0" indent="0" algn="ctr">
-              <a:buNone/>
-            </a:pPr>
-            <a:r>
-              <a:rPr lang="en-US" sz="800" b="1" u="sng" dirty="0">
-                <a:solidFill>
-                  <a:srgbClr val="2A3B50"/>
-                </a:solidFill>
-                <a:latin typeface="Arial" pitchFamily="34" charset="0"/>
-                <a:ea typeface="Arial" pitchFamily="34" charset="-122"/>
-                <a:cs typeface="Arial" pitchFamily="34" charset="-120"/>
-                <a:hlinkClick r:id="rId5" action="ppaction://hlinksldjump">
-                  <a:extLst>
-                    <a:ext uri="{A12FA001-AC4F-418D-AE19-62706E023703}">
-                      <ahyp:hlinkClr xmlns:ahyp="http://schemas.microsoft.com/office/drawing/2018/hyperlinkcolor" val="tx"/>
-                    </a:ext>
-                  </a:extLst>
-                </a:hlinkClick>
-              </a:rPr>
-              <a:t>Rooms</a:t>
-            </a:r>
-            <a:endParaRPr lang="en-US" sz="800" dirty="0"/>
-          </a:p>
-        </p:txBody>
-      </p:sp>
-      <p:sp>
-        <p:nvSpPr>
-          <p:cNvPr id="20" name="Shape 18">
-            <a:hlinkClick r:id="rId6" action="ppaction://hlinksldjump"/>
-          </p:cNvPr>
-          <p:cNvSpPr/>
-          <p:nvPr/>
-        </p:nvSpPr>
-        <p:spPr>
-          <a:xfrm>
-            <a:off x="9317736" y="6455664"/>
-            <a:ext cx="749808" cy="283464"/>
-          </a:xfrm>
-          <a:prstGeom prst="roundRect">
-            <a:avLst>
-              <a:gd name="adj" fmla="val 25806"/>
-            </a:avLst>
-          </a:prstGeom>
-          <a:solidFill>
-            <a:srgbClr val="FFFFFF">
-              <a:alpha val="30000"/>
-            </a:srgbClr>
-          </a:solidFill>
-          <a:ln w="12700">
-            <a:solidFill>
-              <a:srgbClr val="536273">
-                <a:alpha val="50000"/>
-              </a:srgbClr>
-            </a:solidFill>
-            <a:prstDash val="solid"/>
-          </a:ln>
-        </p:spPr>
-        <p:txBody>
-          <a:bodyPr/>
-          <a:lstStyle/>
-          <a:p>
-            <a:endParaRPr lang="en-US"/>
-          </a:p>
-        </p:txBody>
-      </p:sp>
-      <p:sp>
-        <p:nvSpPr>
-          <p:cNvPr id="21" name="Text 19">
-            <a:hlinkClick r:id="rId6" action="ppaction://hlinksldjump"/>
-          </p:cNvPr>
-          <p:cNvSpPr/>
-          <p:nvPr/>
-        </p:nvSpPr>
-        <p:spPr>
-          <a:xfrm>
-            <a:off x="9336024" y="6483096"/>
-            <a:ext cx="713232" cy="182880"/>
-          </a:xfrm>
-          <a:prstGeom prst="rect">
-            <a:avLst/>
-          </a:prstGeom>
-          <a:noFill/>
-          <a:ln/>
-        </p:spPr>
-        <p:txBody>
-          <a:bodyPr wrap="square" lIns="381" tIns="381" rIns="381" bIns="381" rtlCol="0" anchor="ctr">
-            <a:normAutofit/>
-          </a:bodyPr>
-          <a:lstStyle/>
-          <a:p>
-            <a:pPr marL="0" indent="0" algn="ctr">
-              <a:buNone/>
-            </a:pPr>
-            <a:r>
-              <a:rPr lang="en-US" sz="800" b="1" u="sng" dirty="0">
-                <a:solidFill>
-                  <a:srgbClr val="2A3B50"/>
-                </a:solidFill>
-                <a:latin typeface="Arial" pitchFamily="34" charset="0"/>
-                <a:ea typeface="Arial" pitchFamily="34" charset="-122"/>
-                <a:cs typeface="Arial" pitchFamily="34" charset="-120"/>
-                <a:hlinkClick r:id="rId6" action="ppaction://hlinksldjump">
-                  <a:extLst>
-                    <a:ext uri="{A12FA001-AC4F-418D-AE19-62706E023703}">
-                      <ahyp:hlinkClr xmlns:ahyp="http://schemas.microsoft.com/office/drawing/2018/hyperlinkcolor" val="tx"/>
-                    </a:ext>
-                  </a:extLst>
-                </a:hlinkClick>
-              </a:rPr>
-              <a:t>Book</a:t>
-            </a:r>
-            <a:endParaRPr lang="en-US" sz="800" dirty="0"/>
-          </a:p>
-        </p:txBody>
-      </p:sp>
-      <p:sp>
-        <p:nvSpPr>
-          <p:cNvPr id="22" name="Shape 20">
-            <a:hlinkClick r:id="rId7" action="ppaction://hlinksldjump"/>
-          </p:cNvPr>
-          <p:cNvSpPr/>
-          <p:nvPr/>
-        </p:nvSpPr>
-        <p:spPr>
-          <a:xfrm>
-            <a:off x="10158984" y="6455664"/>
-            <a:ext cx="749808" cy="283464"/>
-          </a:xfrm>
-          <a:prstGeom prst="roundRect">
-            <a:avLst>
-              <a:gd name="adj" fmla="val 25806"/>
-            </a:avLst>
-          </a:prstGeom>
-          <a:solidFill>
-            <a:srgbClr val="FFFFFF">
-              <a:alpha val="30000"/>
-            </a:srgbClr>
-          </a:solidFill>
-          <a:ln w="12700">
-            <a:solidFill>
-              <a:srgbClr val="536273">
-                <a:alpha val="50000"/>
-              </a:srgbClr>
-            </a:solidFill>
-            <a:prstDash val="solid"/>
-          </a:ln>
-        </p:spPr>
-        <p:txBody>
-          <a:bodyPr/>
-          <a:lstStyle/>
-          <a:p>
-            <a:endParaRPr lang="en-US"/>
-          </a:p>
-        </p:txBody>
-      </p:sp>
-      <p:sp>
-        <p:nvSpPr>
-          <p:cNvPr id="23" name="Text 21">
-            <a:hlinkClick r:id="rId7" action="ppaction://hlinksldjump"/>
-          </p:cNvPr>
-          <p:cNvSpPr/>
-          <p:nvPr/>
-        </p:nvSpPr>
-        <p:spPr>
-          <a:xfrm>
-            <a:off x="10177272" y="6483096"/>
-            <a:ext cx="713232" cy="182880"/>
-          </a:xfrm>
-          <a:prstGeom prst="rect">
-            <a:avLst/>
-          </a:prstGeom>
-          <a:noFill/>
-          <a:ln/>
-        </p:spPr>
-        <p:txBody>
-          <a:bodyPr wrap="square" lIns="381" tIns="381" rIns="381" bIns="381" rtlCol="0" anchor="ctr">
-            <a:normAutofit/>
-          </a:bodyPr>
-          <a:lstStyle/>
-          <a:p>
-            <a:pPr marL="0" indent="0" algn="ctr">
-              <a:buNone/>
-            </a:pPr>
-            <a:r>
-              <a:rPr lang="en-US" sz="800" b="1" u="sng" dirty="0">
-                <a:solidFill>
-                  <a:srgbClr val="2A3B50"/>
-                </a:solidFill>
-                <a:latin typeface="Arial" pitchFamily="34" charset="0"/>
-                <a:ea typeface="Arial" pitchFamily="34" charset="-122"/>
-                <a:cs typeface="Arial" pitchFamily="34" charset="-120"/>
-                <a:hlinkClick r:id="rId7" action="ppaction://hlinksldjump">
-                  <a:extLst>
-                    <a:ext uri="{A12FA001-AC4F-418D-AE19-62706E023703}">
-                      <ahyp:hlinkClr xmlns:ahyp="http://schemas.microsoft.com/office/drawing/2018/hyperlinkcolor" val="tx"/>
-                    </a:ext>
-                  </a:extLst>
-                </a:hlinkClick>
-              </a:rPr>
-              <a:t>Lookup</a:t>
-            </a:r>
-            <a:endParaRPr lang="en-US" sz="800" dirty="0"/>
-          </a:p>
-        </p:txBody>
-      </p:sp>
-      <p:sp>
-        <p:nvSpPr>
-          <p:cNvPr id="24" name="Shape 22">
-            <a:hlinkClick r:id="rId3" action="ppaction://hlinksldjump"/>
-          </p:cNvPr>
-          <p:cNvSpPr/>
-          <p:nvPr/>
-        </p:nvSpPr>
-        <p:spPr>
-          <a:xfrm>
-            <a:off x="11000232" y="6455664"/>
-            <a:ext cx="868680" cy="283464"/>
-          </a:xfrm>
-          <a:prstGeom prst="roundRect">
-            <a:avLst>
-              <a:gd name="adj" fmla="val 25806"/>
-            </a:avLst>
-          </a:prstGeom>
-          <a:solidFill>
-            <a:srgbClr val="132133"/>
-          </a:solidFill>
-          <a:ln w="12700">
-            <a:solidFill>
-              <a:srgbClr val="132133">
-                <a:alpha val="0"/>
-              </a:srgbClr>
-            </a:solidFill>
-            <a:prstDash val="solid"/>
-          </a:ln>
-        </p:spPr>
-        <p:txBody>
-          <a:bodyPr/>
-          <a:lstStyle/>
-          <a:p>
-            <a:endParaRPr lang="en-US"/>
-          </a:p>
-        </p:txBody>
-      </p:sp>
-      <p:sp>
-        <p:nvSpPr>
-          <p:cNvPr id="25" name="Text 23">
-            <a:hlinkClick r:id="rId3" action="ppaction://hlinksldjump"/>
-          </p:cNvPr>
-          <p:cNvSpPr/>
-          <p:nvPr/>
-        </p:nvSpPr>
-        <p:spPr>
-          <a:xfrm>
-            <a:off x="11018520" y="6483096"/>
-            <a:ext cx="832104" cy="182880"/>
-          </a:xfrm>
-          <a:prstGeom prst="rect">
-            <a:avLst/>
-          </a:prstGeom>
-          <a:noFill/>
-          <a:ln/>
-        </p:spPr>
-        <p:txBody>
-          <a:bodyPr wrap="square" lIns="381" tIns="381" rIns="381" bIns="381" rtlCol="0" anchor="ctr">
-            <a:normAutofit/>
-          </a:bodyPr>
-          <a:lstStyle/>
-          <a:p>
-            <a:pPr marL="0" indent="0" algn="ctr">
-              <a:buNone/>
-            </a:pPr>
-            <a:r>
-              <a:rPr lang="en-US" sz="770" b="1" u="sng" dirty="0">
-                <a:solidFill>
-                  <a:srgbClr val="FFFFFF"/>
-                </a:solidFill>
-                <a:latin typeface="Arial" pitchFamily="34" charset="0"/>
-                <a:ea typeface="Arial" pitchFamily="34" charset="-122"/>
-                <a:cs typeface="Arial" pitchFamily="34" charset="-120"/>
-                <a:hlinkClick r:id="rId3" action="ppaction://hlinksldjump">
-                  <a:extLst>
-                    <a:ext uri="{A12FA001-AC4F-418D-AE19-62706E023703}">
-                      <ahyp:hlinkClr xmlns:ahyp="http://schemas.microsoft.com/office/drawing/2018/hyperlinkcolor" val="tx"/>
-                    </a:ext>
-                  </a:extLst>
-                </a:hlinkClick>
-              </a:rPr>
-              <a:t>Site Flow</a:t>
-            </a:r>
-            <a:endParaRPr lang="en-US" sz="770" dirty="0"/>
           </a:p>
         </p:txBody>
       </p:sp>

</xml_diff>